<commit_message>
Add final PRISM demo video link
</commit_message>
<xml_diff>
--- a/submission/StreamRAG Hackathon Submission.pptx
+++ b/submission/StreamRAG Hackathon Submission.pptx
@@ -13379,16 +13379,7 @@
               <a:buNone/>
             </a:pPr>
             <a:r>
-              <a:rPr b="1" lang="en-US" sz="4400">
-                <a:solidFill>
-                  <a:srgbClr val="704EA6"/>
-                </a:solidFill>
-                <a:latin typeface="Calibri"/>
-                <a:ea typeface="Calibri"/>
-                <a:cs typeface="Calibri"/>
-                <a:sym typeface="Calibri"/>
-              </a:rPr>
-              <a:t>Checklist- Updated on Public GitHub</a:t>
+              <a:t>☑ Checklist- Updated on Public GitHub</a:t>
             </a:r>
             <a:endParaRPr sz="4400">
               <a:solidFill>
@@ -13463,16 +13454,7 @@
               <a:buNone/>
             </a:pPr>
             <a:r>
-              <a:rPr b="0" i="0" lang="en-US" sz="1500" u="none" cap="none" strike="noStrike">
-                <a:solidFill>
-                  <a:srgbClr val="111827"/>
-                </a:solidFill>
-                <a:latin typeface="Inter"/>
-                <a:ea typeface="Inter"/>
-                <a:cs typeface="Inter"/>
-                <a:sym typeface="Inter"/>
-              </a:rPr>
-              <a:t>Working prototype code — public or shared GitHub repo</a:t>
+              <a:t>☑ Working prototype code — public or shared GitHub repo</a:t>
             </a:r>
             <a:endParaRPr/>
           </a:p>
@@ -13587,16 +13569,7 @@
               <a:buNone/>
             </a:pPr>
             <a:r>
-              <a:rPr b="0" i="0" lang="en-US" sz="1500" u="none" cap="none" strike="noStrike">
-                <a:solidFill>
-                  <a:srgbClr val="111827"/>
-                </a:solidFill>
-                <a:latin typeface="Inter"/>
-                <a:ea typeface="Inter"/>
-                <a:cs typeface="Inter"/>
-                <a:sym typeface="Inter"/>
-              </a:rPr>
-              <a:t>README with reproducible setup instructions</a:t>
+              <a:t>☑ README with reproducible setup instructions</a:t>
             </a:r>
             <a:endParaRPr/>
           </a:p>
@@ -13711,16 +13684,7 @@
               <a:buNone/>
             </a:pPr>
             <a:r>
-              <a:rPr b="0" i="0" lang="en-US" sz="1500" u="none" cap="none" strike="noStrike">
-                <a:solidFill>
-                  <a:srgbClr val="111827"/>
-                </a:solidFill>
-                <a:latin typeface="Inter"/>
-                <a:ea typeface="Inter"/>
-                <a:cs typeface="Inter"/>
-                <a:sym typeface="Inter"/>
-              </a:rPr>
-              <a:t>Demo video, max 5 minutes</a:t>
+              <a:t>☑ Demo video, max 5 minutes</a:t>
             </a:r>
             <a:endParaRPr/>
           </a:p>
@@ -13835,16 +13799,7 @@
               <a:buNone/>
             </a:pPr>
             <a:r>
-              <a:rPr b="0" i="0" lang="en-US" sz="1500" u="none" cap="none" strike="noStrike">
-                <a:solidFill>
-                  <a:srgbClr val="111827"/>
-                </a:solidFill>
-                <a:latin typeface="Inter"/>
-                <a:ea typeface="Inter"/>
-                <a:cs typeface="Inter"/>
-                <a:sym typeface="Inter"/>
-              </a:rPr>
-              <a:t>Presentation file (PPT or PDF)</a:t>
+              <a:t>☑ Presentation file (PPT or PDF)</a:t>
             </a:r>
             <a:endParaRPr/>
           </a:p>
@@ -13897,6 +13852,49 @@
               <a:t>(YES )</a:t>
             </a:r>
             <a:endParaRPr/>
+          </a:p>
+        </p:txBody>
+      </p:sp>
+      <p:sp>
+        <p:nvSpPr>
+          <p:cNvPr id="335" name="TextBox 334"/>
+          <p:cNvSpPr txBox="1"/>
+          <p:nvPr/>
+        </p:nvSpPr>
+        <p:spPr>
+          <a:xfrm>
+            <a:off x="914400" y="5486400"/>
+            <a:ext cx="7315200" cy="914400"/>
+          </a:xfrm>
+          <a:prstGeom prst="rect">
+            <a:avLst/>
+          </a:prstGeom>
+          <a:noFill/>
+        </p:spPr>
+        <p:txBody>
+          <a:bodyPr wrap="none">
+            <a:spAutoFit/>
+          </a:bodyPr>
+          <a:lstStyle/>
+          <a:p/>
+          <a:p>
+            <a:pPr>
+              <a:defRPr b="1" sz="1400"/>
+            </a:pPr>
+            <a:r>
+              <a:t>Official Samsung PRISM Theme 4 Demo Video:</a:t>
+            </a:r>
+          </a:p>
+          <a:p>
+            <a:pPr>
+              <a:defRPr sz="1200"/>
+            </a:pPr>
+            <a:r>
+              <a:rPr>
+                <a:hlinkClick r:id="rId3"/>
+              </a:rPr>
+              <a:t>https://drive.google.com/file/d/1i0GMIBYXcqjJvhEG8op0SK2mIyaaOcXd/view?usp=drive_link</a:t>
+            </a:r>
           </a:p>
         </p:txBody>
       </p:sp>

</xml_diff>